<commit_message>
final pptx edits before sending
</commit_message>
<xml_diff>
--- a/Presentations/MA_Final_Presentation.pptx
+++ b/Presentations/MA_Final_Presentation.pptx
@@ -4042,7 +4042,7 @@
           <a:p>
             <a:fld id="{2B685DCD-866D-47AE-A236-118539F53379}" type="slidenum">
               <a:rPr lang="de-CH" smtClean="0"/>
-              <a:t>‹Nr.›</a:t>
+              <a:t>‹#›</a:t>
             </a:fld>
             <a:endParaRPr lang="de-CH"/>
           </a:p>
@@ -4300,7 +4300,7 @@
           <a:p>
             <a:fld id="{F615DDFD-030C-4D5A-B33E-3A7E7538D2BE}" type="slidenum">
               <a:rPr lang="de-CH" smtClean="0"/>
-              <a:t>‹Nr.›</a:t>
+              <a:t>‹#›</a:t>
             </a:fld>
             <a:endParaRPr lang="de-CH"/>
           </a:p>
@@ -7454,7 +7454,7 @@
           <a:p>
             <a:fld id="{5ACA52AF-F19D-405C-AD5F-7D94B96A5CC3}" type="slidenum">
               <a:rPr lang="de-CH" noProof="0" smtClean="0"/>
-              <a:t>‹Nr.›</a:t>
+              <a:t>‹#›</a:t>
             </a:fld>
             <a:endParaRPr lang="de-CH" noProof="0"/>
           </a:p>
@@ -7649,7 +7649,7 @@
           <a:p>
             <a:fld id="{5ACA52AF-F19D-405C-AD5F-7D94B96A5CC3}" type="slidenum">
               <a:rPr lang="de-CH" noProof="0" smtClean="0"/>
-              <a:t>‹Nr.›</a:t>
+              <a:t>‹#›</a:t>
             </a:fld>
             <a:endParaRPr lang="de-CH" noProof="0"/>
           </a:p>
@@ -7936,7 +7936,7 @@
           <a:p>
             <a:fld id="{5ACA52AF-F19D-405C-AD5F-7D94B96A5CC3}" type="slidenum">
               <a:rPr lang="de-CH" noProof="0" smtClean="0"/>
-              <a:t>‹Nr.›</a:t>
+              <a:t>‹#›</a:t>
             </a:fld>
             <a:endParaRPr lang="de-CH" noProof="0"/>
           </a:p>
@@ -8234,7 +8234,7 @@
           <a:p>
             <a:fld id="{5ACA52AF-F19D-405C-AD5F-7D94B96A5CC3}" type="slidenum">
               <a:rPr lang="de-CH" noProof="0" smtClean="0"/>
-              <a:t>‹Nr.›</a:t>
+              <a:t>‹#›</a:t>
             </a:fld>
             <a:endParaRPr lang="de-CH" noProof="0"/>
           </a:p>
@@ -8634,7 +8634,7 @@
           <a:p>
             <a:fld id="{5ACA52AF-F19D-405C-AD5F-7D94B96A5CC3}" type="slidenum">
               <a:rPr lang="de-CH" noProof="0" smtClean="0"/>
-              <a:t>‹Nr.›</a:t>
+              <a:t>‹#›</a:t>
             </a:fld>
             <a:endParaRPr lang="de-CH" noProof="0"/>
           </a:p>
@@ -9002,7 +9002,7 @@
           <a:p>
             <a:fld id="{5ACA52AF-F19D-405C-AD5F-7D94B96A5CC3}" type="slidenum">
               <a:rPr lang="de-CH" noProof="0" smtClean="0"/>
-              <a:t>‹Nr.›</a:t>
+              <a:t>‹#›</a:t>
             </a:fld>
             <a:endParaRPr lang="de-CH" noProof="0"/>
           </a:p>
@@ -11031,7 +11031,7 @@
           <a:p>
             <a:fld id="{5ACA52AF-F19D-405C-AD5F-7D94B96A5CC3}" type="slidenum">
               <a:rPr lang="de-CH" noProof="0" smtClean="0"/>
-              <a:t>‹Nr.›</a:t>
+              <a:t>‹#›</a:t>
             </a:fld>
             <a:endParaRPr lang="de-CH" noProof="0"/>
           </a:p>
@@ -11274,7 +11274,7 @@
           <a:p>
             <a:fld id="{5ACA52AF-F19D-405C-AD5F-7D94B96A5CC3}" type="slidenum">
               <a:rPr lang="de-CH" noProof="0" smtClean="0"/>
-              <a:t>‹Nr.›</a:t>
+              <a:t>‹#›</a:t>
             </a:fld>
             <a:endParaRPr lang="de-CH" noProof="0"/>
           </a:p>
@@ -11522,7 +11522,7 @@
           <a:p>
             <a:fld id="{5ACA52AF-F19D-405C-AD5F-7D94B96A5CC3}" type="slidenum">
               <a:rPr lang="de-CH" noProof="0" smtClean="0"/>
-              <a:t>‹Nr.›</a:t>
+              <a:t>‹#›</a:t>
             </a:fld>
             <a:endParaRPr lang="de-CH" noProof="0"/>
           </a:p>
@@ -11815,7 +11815,7 @@
             <a:fld id="{5ACA52AF-F19D-405C-AD5F-7D94B96A5CC3}" type="slidenum">
               <a:rPr lang="de-CH" noProof="0" smtClean="0"/>
               <a:pPr/>
-              <a:t>‹Nr.›</a:t>
+              <a:t>‹#›</a:t>
             </a:fld>
             <a:endParaRPr lang="de-CH" noProof="0"/>
           </a:p>
@@ -13758,7 +13758,7 @@
             <a:fld id="{5ACA52AF-F19D-405C-AD5F-7D94B96A5CC3}" type="slidenum">
               <a:rPr lang="de-CH" noProof="0" smtClean="0"/>
               <a:pPr/>
-              <a:t>‹Nr.›</a:t>
+              <a:t>‹#›</a:t>
             </a:fld>
             <a:endParaRPr lang="de-CH" noProof="0"/>
           </a:p>
@@ -24651,7 +24651,7 @@
         <p:spPr>
           <a:xfrm>
             <a:off x="177764" y="809018"/>
-            <a:ext cx="7432532" cy="3688136"/>
+            <a:ext cx="6944396" cy="3445915"/>
           </a:xfrm>
           <a:prstGeom prst="rect">
             <a:avLst/>
@@ -24672,8 +24672,8 @@
         </p:nvSpPr>
         <p:spPr>
           <a:xfrm>
-            <a:off x="7731889" y="726583"/>
-            <a:ext cx="4460111" cy="3854901"/>
+            <a:off x="7274561" y="614823"/>
+            <a:ext cx="4917440" cy="3439403"/>
           </a:xfrm>
           <a:prstGeom prst="rect">
             <a:avLst/>
@@ -24734,7 +24734,7 @@
               <a:buFont typeface="Wingdings" panose="05000000000000000000" pitchFamily="2" charset="2"/>
               <a:buChar char="Ø"/>
             </a:pPr>
-            <a:endParaRPr lang="en-US" sz="1050" dirty="0"/>
+            <a:endParaRPr lang="en-US" sz="700" dirty="0"/>
           </a:p>
           <a:p>
             <a:pPr marL="285750" indent="-285750">
@@ -24766,7 +24766,7 @@
             </a:r>
           </a:p>
           <a:p>
-            <a:endParaRPr lang="en-US" dirty="0"/>
+            <a:endParaRPr lang="en-US" sz="900" dirty="0"/>
           </a:p>
           <a:p>
             <a:r>
@@ -24822,8 +24822,8 @@
         </p:nvSpPr>
         <p:spPr>
           <a:xfrm>
-            <a:off x="9188904" y="4891785"/>
-            <a:ext cx="2767746" cy="1323439"/>
+            <a:off x="8471424" y="4456509"/>
+            <a:ext cx="3605940" cy="2031325"/>
           </a:xfrm>
           <a:prstGeom prst="rect">
             <a:avLst/>
@@ -24836,11 +24836,11 @@
           </a:bodyPr>
           <a:lstStyle/>
           <a:p>
-            <a:pPr algn="ctr"/>
-            <a:r>
-              <a:rPr lang="en-US" sz="2000" b="1" dirty="0"/>
-              <a:t>Later confirmed independently by the churn classifier's SFS feature selection</a:t>
-            </a:r>
+            <a:r>
+              <a:rPr lang="en-US" dirty="0"/>
+              <a:t>The model derived the full behavioral pattern from just a few targeted features, confirming that engagement with specific catalog anchors, more than just broad diversity metrics, is the decisive predictor of retention</a:t>
+            </a:r>
+            <a:endParaRPr lang="en-US" b="1" dirty="0"/>
           </a:p>
         </p:txBody>
       </p:sp>
@@ -24858,8 +24858,8 @@
         </p:nvSpPr>
         <p:spPr>
           <a:xfrm>
-            <a:off x="206076" y="4817301"/>
-            <a:ext cx="3868214" cy="1384995"/>
+            <a:off x="114636" y="4299141"/>
+            <a:ext cx="3847764" cy="1923604"/>
           </a:xfrm>
           <a:prstGeom prst="rect">
             <a:avLst/>
@@ -24873,17 +24873,18 @@
           <a:lstStyle/>
           <a:p>
             <a:r>
-              <a:rPr lang="en-US" sz="2000" b="1" dirty="0"/>
+              <a:rPr lang="en-US" b="1" dirty="0"/>
               <a:t>Why this matters for modeling</a:t>
             </a:r>
-          </a:p>
-          <a:p>
-            <a:endParaRPr lang="en-US" sz="1000" b="1" dirty="0"/>
-          </a:p>
-          <a:p>
-            <a:r>
-              <a:rPr lang="en-US" dirty="0"/>
-              <a:t>Loyalty is not driven by which cluster a customer prefers, but by the diversity of their engagement </a:t>
+            <a:endParaRPr lang="en-US" sz="2000" b="1" dirty="0"/>
+          </a:p>
+          <a:p>
+            <a:endParaRPr lang="en-US" sz="500" b="1" dirty="0"/>
+          </a:p>
+          <a:p>
+            <a:r>
+              <a:rPr lang="en-US" sz="1600" dirty="0"/>
+              <a:t>This behavioral insight motivated the use of Style Entropy and Cluster Affinity features: Style Entropy to capture overall diversity, individual Cluster Affinities to capture engagement with specific product categories</a:t>
             </a:r>
           </a:p>
         </p:txBody>
@@ -24902,8 +24903,8 @@
         </p:nvSpPr>
         <p:spPr>
           <a:xfrm>
-            <a:off x="4813825" y="4753286"/>
-            <a:ext cx="3774589" cy="1600438"/>
+            <a:off x="4358296" y="4254933"/>
+            <a:ext cx="3383537" cy="2446824"/>
           </a:xfrm>
           <a:prstGeom prst="rect">
             <a:avLst/>
@@ -24917,24 +24918,17 @@
           <a:lstStyle/>
           <a:p>
             <a:r>
-              <a:rPr lang="en-US" sz="2000" b="1" dirty="0"/>
-              <a:t>This is formalized as Style Entropy</a:t>
-            </a:r>
-            <a:br>
-              <a:rPr lang="en-US" sz="2000" b="1" u="sng" dirty="0"/>
-            </a:br>
-            <a:r>
-              <a:rPr lang="en-US" sz="1200" dirty="0"/>
-              <a:t>(Shannon entropy across cluster affinity shares)</a:t>
-            </a:r>
-          </a:p>
-          <a:p>
-            <a:endParaRPr lang="en-US" sz="1000" dirty="0"/>
-          </a:p>
-          <a:p>
-            <a:r>
-              <a:rPr lang="en-US" dirty="0"/>
-              <a:t>The primary early-warning signal for latent attrition </a:t>
+              <a:rPr lang="en-US" b="1" dirty="0"/>
+              <a:t>SFS eliminated Style Entropy as redundant</a:t>
+            </a:r>
+          </a:p>
+          <a:p>
+            <a:endParaRPr lang="en-US" sz="500" dirty="0"/>
+          </a:p>
+          <a:p>
+            <a:r>
+              <a:rPr lang="en-US" sz="1600" dirty="0"/>
+              <a:t>Once specific Cluster Affinities were included, the diversity signal was already captured. Not all affinities were needed either: only the economic anchors identified in the business profiling (Bags, Tops, Dresses, Jackets)</a:t>
             </a:r>
           </a:p>
         </p:txBody>
@@ -24953,7 +24947,7 @@
         </p:nvCxnSpPr>
         <p:spPr>
           <a:xfrm>
-            <a:off x="4004841" y="5602147"/>
+            <a:off x="3547641" y="5472172"/>
             <a:ext cx="739535" cy="0"/>
           </a:xfrm>
           <a:prstGeom prst="straightConnector1">
@@ -24995,7 +24989,7 @@
         </p:nvCxnSpPr>
         <p:spPr>
           <a:xfrm>
-            <a:off x="8391649" y="5602147"/>
+            <a:off x="7731889" y="5632627"/>
             <a:ext cx="739535" cy="0"/>
           </a:xfrm>
           <a:prstGeom prst="straightConnector1">
@@ -30908,9 +30902,12 @@
 </file>
 
 <file path=customXml/item1.xml><?xml version="1.0" encoding="utf-8"?>
-<p:properties xmlns:p="http://schemas.microsoft.com/office/2006/metadata/properties" xmlns:xsi="http://www.w3.org/2001/XMLSchema-instance" xmlns:pc="http://schemas.microsoft.com/office/infopath/2007/PartnerControls">
-  <documentManagement/>
-</p:properties>
+<?mso-contentType ?>
+<FormTemplates xmlns="http://schemas.microsoft.com/sharepoint/v3/contenttype/forms">
+  <Display>DocumentLibraryForm</Display>
+  <Edit>DocumentLibraryForm</Edit>
+  <New>DocumentLibraryForm</New>
+</FormTemplates>
 </file>
 
 <file path=customXml/item2.xml><?xml version="1.0" encoding="utf-8"?>
@@ -31076,26 +31073,15 @@
 </file>
 
 <file path=customXml/item3.xml><?xml version="1.0" encoding="utf-8"?>
-<?mso-contentType ?>
-<FormTemplates xmlns="http://schemas.microsoft.com/sharepoint/v3/contenttype/forms">
-  <Display>DocumentLibraryForm</Display>
-  <Edit>DocumentLibraryForm</Edit>
-  <New>DocumentLibraryForm</New>
-</FormTemplates>
+<p:properties xmlns:p="http://schemas.microsoft.com/office/2006/metadata/properties" xmlns:xsi="http://www.w3.org/2001/XMLSchema-instance" xmlns:pc="http://schemas.microsoft.com/office/infopath/2007/PartnerControls">
+  <documentManagement/>
+</p:properties>
 </file>
 
 <file path=customXml/itemProps1.xml><?xml version="1.0" encoding="utf-8"?>
-<ds:datastoreItem xmlns:ds="http://schemas.openxmlformats.org/officeDocument/2006/customXml" ds:itemID="{2C3B1C8D-BA84-44B8-B31F-BF26E7BAC85C}">
+<ds:datastoreItem xmlns:ds="http://schemas.openxmlformats.org/officeDocument/2006/customXml" ds:itemID="{E0CFCB78-2973-46E2-963D-C72C98C43B41}">
   <ds:schemaRefs>
-    <ds:schemaRef ds:uri="7fd05bba-d45d-467f-a5a8-3f2970e80e4a"/>
-    <ds:schemaRef ds:uri="http://schemas.microsoft.com/office/2006/documentManagement/types"/>
-    <ds:schemaRef ds:uri="http://schemas.microsoft.com/office/2006/metadata/properties"/>
-    <ds:schemaRef ds:uri="http://schemas.openxmlformats.org/package/2006/metadata/core-properties"/>
-    <ds:schemaRef ds:uri="http://purl.org/dc/dcmitype/"/>
-    <ds:schemaRef ds:uri="http://purl.org/dc/terms/"/>
-    <ds:schemaRef ds:uri="http://www.w3.org/XML/1998/namespace"/>
-    <ds:schemaRef ds:uri="http://purl.org/dc/elements/1.1/"/>
-    <ds:schemaRef ds:uri="http://schemas.microsoft.com/office/infopath/2007/PartnerControls"/>
+    <ds:schemaRef ds:uri="http://schemas.microsoft.com/sharepoint/v3/contenttype/forms"/>
   </ds:schemaRefs>
 </ds:datastoreItem>
 </file>
@@ -31119,9 +31105,17 @@
 </file>
 
 <file path=customXml/itemProps3.xml><?xml version="1.0" encoding="utf-8"?>
-<ds:datastoreItem xmlns:ds="http://schemas.openxmlformats.org/officeDocument/2006/customXml" ds:itemID="{E0CFCB78-2973-46E2-963D-C72C98C43B41}">
+<ds:datastoreItem xmlns:ds="http://schemas.openxmlformats.org/officeDocument/2006/customXml" ds:itemID="{2C3B1C8D-BA84-44B8-B31F-BF26E7BAC85C}">
   <ds:schemaRefs>
-    <ds:schemaRef ds:uri="http://schemas.microsoft.com/sharepoint/v3/contenttype/forms"/>
+    <ds:schemaRef ds:uri="7fd05bba-d45d-467f-a5a8-3f2970e80e4a"/>
+    <ds:schemaRef ds:uri="http://schemas.microsoft.com/office/2006/documentManagement/types"/>
+    <ds:schemaRef ds:uri="http://schemas.microsoft.com/office/2006/metadata/properties"/>
+    <ds:schemaRef ds:uri="http://schemas.openxmlformats.org/package/2006/metadata/core-properties"/>
+    <ds:schemaRef ds:uri="http://purl.org/dc/dcmitype/"/>
+    <ds:schemaRef ds:uri="http://purl.org/dc/terms/"/>
+    <ds:schemaRef ds:uri="http://www.w3.org/XML/1998/namespace"/>
+    <ds:schemaRef ds:uri="http://purl.org/dc/elements/1.1/"/>
+    <ds:schemaRef ds:uri="http://schemas.microsoft.com/office/infopath/2007/PartnerControls"/>
   </ds:schemaRefs>
 </ds:datastoreItem>
 </file>
</xml_diff>